<commit_message>
Hardcode activity descriptor font to 12pt and update template
Removes the shrink-to-fit autofit logic in favor of a fixed 12pt size
matching the updated template's box dimensions.

Co-Authored-By: Claude Sonnet 5 <noreply@anthropic.com>
Claude-Session: https://claude.ai/code/session_01TjG5u5nVPTTkuy4cpPisG3
</commit_message>
<xml_diff>
--- a/templates/activity_descriptor.pptx
+++ b/templates/activity_descriptor.pptx
@@ -285,8 +285,8 @@
         </p:nvSpPr>
         <p:spPr bwMode="auto">
           <a:xfrm>
-            <a:off x="469899" y="7776754"/>
-            <a:ext cx="6835775" cy="1829833"/>
+            <a:off x="469899" y="8202277"/>
+            <a:ext cx="6835775" cy="1404310"/>
           </a:xfrm>
           <a:prstGeom prst="rect">
             <a:avLst/>
@@ -350,8 +350,8 @@
         </p:nvSpPr>
         <p:spPr bwMode="auto">
           <a:xfrm>
-            <a:off x="469899" y="5070654"/>
-            <a:ext cx="6835775" cy="2610308"/>
+            <a:off x="469899" y="5777388"/>
+            <a:ext cx="6835775" cy="2343418"/>
           </a:xfrm>
           <a:prstGeom prst="rect">
             <a:avLst/>
@@ -415,8 +415,8 @@
         </p:nvSpPr>
         <p:spPr bwMode="auto">
           <a:xfrm>
-            <a:off x="469899" y="3026044"/>
-            <a:ext cx="6835775" cy="1948818"/>
+            <a:off x="469899" y="3026043"/>
+            <a:ext cx="6835775" cy="2669874"/>
           </a:xfrm>
           <a:prstGeom prst="rect">
             <a:avLst/>
@@ -480,8 +480,8 @@
         </p:nvSpPr>
         <p:spPr bwMode="auto">
           <a:xfrm rot="5400000">
-            <a:off x="-427516" y="3920283"/>
-            <a:ext cx="1948818" cy="160338"/>
+            <a:off x="-788044" y="4280811"/>
+            <a:ext cx="2669874" cy="160338"/>
           </a:xfrm>
           <a:prstGeom prst="rect">
             <a:avLst/>
@@ -543,8 +543,8 @@
         </p:nvSpPr>
         <p:spPr bwMode="auto">
           <a:xfrm rot="5400000">
-            <a:off x="-758262" y="6295641"/>
-            <a:ext cx="2610309" cy="160338"/>
+            <a:off x="-624818" y="6868930"/>
+            <a:ext cx="2343421" cy="160338"/>
           </a:xfrm>
           <a:prstGeom prst="rect">
             <a:avLst/>
@@ -648,8 +648,8 @@
         </p:nvSpPr>
         <p:spPr bwMode="auto">
           <a:xfrm rot="5400000">
-            <a:off x="-368845" y="8612269"/>
-            <a:ext cx="1831475" cy="160338"/>
+            <a:off x="-156056" y="8825059"/>
+            <a:ext cx="1405897" cy="160338"/>
           </a:xfrm>
           <a:prstGeom prst="rect">
             <a:avLst/>
@@ -817,8 +817,8 @@
         </p:nvSpPr>
         <p:spPr bwMode="auto">
           <a:xfrm>
-            <a:off x="690880" y="2493764"/>
-            <a:ext cx="6400800" cy="6716713"/>
+            <a:off x="685799" y="2511694"/>
+            <a:ext cx="6400800" cy="418558"/>
           </a:xfrm>
           <a:prstGeom prst="rect">
             <a:avLst/>
@@ -895,6 +895,71 @@
               <a:t>Date:</a:t>
             </a:r>
           </a:p>
+        </p:txBody>
+      </p:sp>
+      <p:sp>
+        <p:nvSpPr>
+          <p:cNvPr id="3" name="Text Box 6">
+            <a:extLst>
+              <a:ext uri="{FF2B5EF4-FFF2-40B4-BE49-F238E27FC236}">
+                <a16:creationId xmlns:a16="http://schemas.microsoft.com/office/drawing/2014/main" id="{21A873ED-892F-BC1F-F0EF-72E4738ECE78}"/>
+              </a:ext>
+            </a:extLst>
+          </p:cNvPr>
+          <p:cNvSpPr txBox="1">
+            <a:spLocks noChangeArrowheads="1"/>
+          </p:cNvSpPr>
+          <p:nvPr userDrawn="1"/>
+        </p:nvSpPr>
+        <p:spPr bwMode="auto">
+          <a:xfrm>
+            <a:off x="685799" y="3033009"/>
+            <a:ext cx="6400800" cy="418558"/>
+          </a:xfrm>
+          <a:prstGeom prst="rect">
+            <a:avLst/>
+          </a:prstGeom>
+          <a:noFill/>
+          <a:ln>
+            <a:noFill/>
+          </a:ln>
+          <a:effectLst/>
+          <a:extLst>
+            <a:ext uri="{909E8E84-426E-40DD-AFC4-6F175D3DCCD1}">
+              <a14:hiddenFill xmlns:a14="http://schemas.microsoft.com/office/drawing/2010/main">
+                <a:solidFill>
+                  <a:srgbClr val="FFFFFF"/>
+                </a:solidFill>
+              </a14:hiddenFill>
+            </a:ext>
+            <a:ext uri="{91240B29-F687-4F45-9708-019B960494DF}">
+              <a14:hiddenLine xmlns:a14="http://schemas.microsoft.com/office/drawing/2010/main" w="25400" algn="ctr">
+                <a:solidFill>
+                  <a:srgbClr val="000000"/>
+                </a:solidFill>
+                <a:miter lim="800000"/>
+                <a:headEnd/>
+                <a:tailEnd/>
+              </a14:hiddenLine>
+            </a:ext>
+            <a:ext uri="{AF507438-7753-43E0-B8FC-AC1667EBCBE1}">
+              <a14:hiddenEffects xmlns:a14="http://schemas.microsoft.com/office/drawing/2010/main">
+                <a:effectLst>
+                  <a:outerShdw dist="35921" dir="2700000" algn="ctr" rotWithShape="0">
+                    <a:srgbClr val="EEECE1"/>
+                  </a:outerShdw>
+                </a:effectLst>
+              </a14:hiddenEffects>
+            </a:ext>
+          </a:extLst>
+        </p:spPr>
+        <p:txBody>
+          <a:bodyPr vert="horz" wrap="square" lIns="36576" tIns="36576" rIns="36576" bIns="36576" numCol="1" anchor="t" anchorCtr="0" compatLnSpc="1">
+            <a:prstTxWarp prst="textNoShape">
+              <a:avLst/>
+            </a:prstTxWarp>
+          </a:bodyPr>
+          <a:lstStyle/>
           <a:p>
             <a:pPr marL="0" marR="0" lvl="0" indent="0" algn="l" defTabSz="914400" rtl="0" eaLnBrk="0" fontAlgn="base" latinLnBrk="0" hangingPunct="0">
               <a:lnSpc>
@@ -904,7 +969,7 @@
                 <a:spcPct val="0"/>
               </a:spcBef>
               <a:spcAft>
-                <a:spcPts val="3000"/>
+                <a:spcPts val="1200"/>
               </a:spcAft>
               <a:buClrTx/>
               <a:buSzTx/>
@@ -926,6 +991,71 @@
               <a:t>Activity:</a:t>
             </a:r>
           </a:p>
+        </p:txBody>
+      </p:sp>
+      <p:sp>
+        <p:nvSpPr>
+          <p:cNvPr id="5" name="Text Box 6">
+            <a:extLst>
+              <a:ext uri="{FF2B5EF4-FFF2-40B4-BE49-F238E27FC236}">
+                <a16:creationId xmlns:a16="http://schemas.microsoft.com/office/drawing/2014/main" id="{7403847F-5176-DDBD-AC29-8C91005CC41F}"/>
+              </a:ext>
+            </a:extLst>
+          </p:cNvPr>
+          <p:cNvSpPr txBox="1">
+            <a:spLocks noChangeArrowheads="1"/>
+          </p:cNvSpPr>
+          <p:nvPr userDrawn="1"/>
+        </p:nvSpPr>
+        <p:spPr bwMode="auto">
+          <a:xfrm>
+            <a:off x="698187" y="5792165"/>
+            <a:ext cx="6400800" cy="418558"/>
+          </a:xfrm>
+          <a:prstGeom prst="rect">
+            <a:avLst/>
+          </a:prstGeom>
+          <a:noFill/>
+          <a:ln>
+            <a:noFill/>
+          </a:ln>
+          <a:effectLst/>
+          <a:extLst>
+            <a:ext uri="{909E8E84-426E-40DD-AFC4-6F175D3DCCD1}">
+              <a14:hiddenFill xmlns:a14="http://schemas.microsoft.com/office/drawing/2010/main">
+                <a:solidFill>
+                  <a:srgbClr val="FFFFFF"/>
+                </a:solidFill>
+              </a14:hiddenFill>
+            </a:ext>
+            <a:ext uri="{91240B29-F687-4F45-9708-019B960494DF}">
+              <a14:hiddenLine xmlns:a14="http://schemas.microsoft.com/office/drawing/2010/main" w="25400" algn="ctr">
+                <a:solidFill>
+                  <a:srgbClr val="000000"/>
+                </a:solidFill>
+                <a:miter lim="800000"/>
+                <a:headEnd/>
+                <a:tailEnd/>
+              </a14:hiddenLine>
+            </a:ext>
+            <a:ext uri="{AF507438-7753-43E0-B8FC-AC1667EBCBE1}">
+              <a14:hiddenEffects xmlns:a14="http://schemas.microsoft.com/office/drawing/2010/main">
+                <a:effectLst>
+                  <a:outerShdw dist="35921" dir="2700000" algn="ctr" rotWithShape="0">
+                    <a:srgbClr val="EEECE1"/>
+                  </a:outerShdw>
+                </a:effectLst>
+              </a14:hiddenEffects>
+            </a:ext>
+          </a:extLst>
+        </p:spPr>
+        <p:txBody>
+          <a:bodyPr vert="horz" wrap="square" lIns="36576" tIns="36576" rIns="36576" bIns="36576" numCol="1" anchor="t" anchorCtr="0" compatLnSpc="1">
+            <a:prstTxWarp prst="textNoShape">
+              <a:avLst/>
+            </a:prstTxWarp>
+          </a:bodyPr>
+          <a:lstStyle/>
           <a:p>
             <a:pPr marL="0" marR="0" lvl="0" indent="0" algn="l" defTabSz="914400" rtl="0" eaLnBrk="0" fontAlgn="base" latinLnBrk="0" hangingPunct="0">
               <a:lnSpc>
@@ -935,7 +1065,7 @@
                 <a:spcPct val="0"/>
               </a:spcBef>
               <a:spcAft>
-                <a:spcPts val="900"/>
+                <a:spcPts val="1200"/>
               </a:spcAft>
               <a:buClrTx/>
               <a:buSzTx/>
@@ -943,17 +1073,85 @@
               <a:buNone/>
               <a:tabLst/>
             </a:pPr>
-            <a:endParaRPr kumimoji="0" lang="en-US" altLang="en-US" sz="2200" b="1" i="0" u="none" strike="noStrike" cap="none" normalizeH="0" baseline="0" dirty="0">
-              <a:ln>
-                <a:noFill/>
-              </a:ln>
-              <a:solidFill>
-                <a:srgbClr val="000000"/>
-              </a:solidFill>
-              <a:effectLst/>
-              <a:latin typeface="Tw Cen MT" panose="020B0602020104020603" pitchFamily="34" charset="0"/>
-            </a:endParaRPr>
-          </a:p>
+            <a:r>
+              <a:rPr kumimoji="0" lang="en-US" altLang="en-US" sz="2200" b="1" i="0" u="none" strike="noStrike" cap="none" normalizeH="0" baseline="0" dirty="0">
+                <a:ln>
+                  <a:noFill/>
+                </a:ln>
+                <a:solidFill>
+                  <a:srgbClr val="000000"/>
+                </a:solidFill>
+                <a:effectLst/>
+                <a:latin typeface="Tw Cen MT" panose="020B0602020104020603" pitchFamily="34" charset="0"/>
+              </a:rPr>
+              <a:t>Skills Learned:</a:t>
+            </a:r>
+          </a:p>
+        </p:txBody>
+      </p:sp>
+      <p:sp>
+        <p:nvSpPr>
+          <p:cNvPr id="7" name="Text Box 6">
+            <a:extLst>
+              <a:ext uri="{FF2B5EF4-FFF2-40B4-BE49-F238E27FC236}">
+                <a16:creationId xmlns:a16="http://schemas.microsoft.com/office/drawing/2014/main" id="{E652F733-1A2C-6C23-2EF3-D7CEB0C69D33}"/>
+              </a:ext>
+            </a:extLst>
+          </p:cNvPr>
+          <p:cNvSpPr txBox="1">
+            <a:spLocks noChangeArrowheads="1"/>
+          </p:cNvSpPr>
+          <p:nvPr userDrawn="1"/>
+        </p:nvSpPr>
+        <p:spPr bwMode="auto">
+          <a:xfrm>
+            <a:off x="685799" y="8188192"/>
+            <a:ext cx="6400800" cy="418558"/>
+          </a:xfrm>
+          <a:prstGeom prst="rect">
+            <a:avLst/>
+          </a:prstGeom>
+          <a:noFill/>
+          <a:ln>
+            <a:noFill/>
+          </a:ln>
+          <a:effectLst/>
+          <a:extLst>
+            <a:ext uri="{909E8E84-426E-40DD-AFC4-6F175D3DCCD1}">
+              <a14:hiddenFill xmlns:a14="http://schemas.microsoft.com/office/drawing/2010/main">
+                <a:solidFill>
+                  <a:srgbClr val="FFFFFF"/>
+                </a:solidFill>
+              </a14:hiddenFill>
+            </a:ext>
+            <a:ext uri="{91240B29-F687-4F45-9708-019B960494DF}">
+              <a14:hiddenLine xmlns:a14="http://schemas.microsoft.com/office/drawing/2010/main" w="25400" algn="ctr">
+                <a:solidFill>
+                  <a:srgbClr val="000000"/>
+                </a:solidFill>
+                <a:miter lim="800000"/>
+                <a:headEnd/>
+                <a:tailEnd/>
+              </a14:hiddenLine>
+            </a:ext>
+            <a:ext uri="{AF507438-7753-43E0-B8FC-AC1667EBCBE1}">
+              <a14:hiddenEffects xmlns:a14="http://schemas.microsoft.com/office/drawing/2010/main">
+                <a:effectLst>
+                  <a:outerShdw dist="35921" dir="2700000" algn="ctr" rotWithShape="0">
+                    <a:srgbClr val="EEECE1"/>
+                  </a:outerShdw>
+                </a:effectLst>
+              </a14:hiddenEffects>
+            </a:ext>
+          </a:extLst>
+        </p:spPr>
+        <p:txBody>
+          <a:bodyPr vert="horz" wrap="square" lIns="36576" tIns="36576" rIns="36576" bIns="36576" numCol="1" anchor="t" anchorCtr="0" compatLnSpc="1">
+            <a:prstTxWarp prst="textNoShape">
+              <a:avLst/>
+            </a:prstTxWarp>
+          </a:bodyPr>
+          <a:lstStyle/>
           <a:p>
             <a:pPr marL="0" marR="0" lvl="0" indent="0" algn="l" defTabSz="914400" rtl="0" eaLnBrk="0" fontAlgn="base" latinLnBrk="0" hangingPunct="0">
               <a:lnSpc>
@@ -963,7 +1161,7 @@
                 <a:spcPct val="0"/>
               </a:spcBef>
               <a:spcAft>
-                <a:spcPts val="900"/>
+                <a:spcPts val="1200"/>
               </a:spcAft>
               <a:buClrTx/>
               <a:buSzTx/>
@@ -971,62 +1169,6 @@
               <a:buNone/>
               <a:tabLst/>
             </a:pPr>
-            <a:endParaRPr kumimoji="0" lang="en-US" altLang="en-US" sz="2200" b="1" i="0" u="none" strike="noStrike" cap="none" normalizeH="0" baseline="0" dirty="0">
-              <a:ln>
-                <a:noFill/>
-              </a:ln>
-              <a:solidFill>
-                <a:srgbClr val="000000"/>
-              </a:solidFill>
-              <a:effectLst/>
-              <a:latin typeface="Tw Cen MT" panose="020B0602020104020603" pitchFamily="34" charset="0"/>
-            </a:endParaRPr>
-          </a:p>
-          <a:p>
-            <a:pPr marL="0" marR="0" lvl="0" indent="0" algn="l" defTabSz="914400" rtl="0" eaLnBrk="0" fontAlgn="base" latinLnBrk="0" hangingPunct="0">
-              <a:lnSpc>
-                <a:spcPct val="100000"/>
-              </a:lnSpc>
-              <a:spcBef>
-                <a:spcPct val="0"/>
-              </a:spcBef>
-              <a:spcAft>
-                <a:spcPts val="900"/>
-              </a:spcAft>
-              <a:buClrTx/>
-              <a:buSzTx/>
-              <a:buFontTx/>
-              <a:buNone/>
-              <a:tabLst/>
-            </a:pPr>
-            <a:endParaRPr kumimoji="0" lang="en-US" altLang="en-US" sz="2200" b="1" i="0" u="none" strike="noStrike" cap="none" normalizeH="0" baseline="0" dirty="0">
-              <a:ln>
-                <a:noFill/>
-              </a:ln>
-              <a:solidFill>
-                <a:srgbClr val="000000"/>
-              </a:solidFill>
-              <a:effectLst/>
-              <a:latin typeface="Tw Cen MT" panose="020B0602020104020603" pitchFamily="34" charset="0"/>
-            </a:endParaRPr>
-          </a:p>
-          <a:p>
-            <a:pPr marL="0" marR="0" lvl="0" indent="0" algn="l" defTabSz="914400" rtl="0" eaLnBrk="0" fontAlgn="base" latinLnBrk="0" hangingPunct="0">
-              <a:lnSpc>
-                <a:spcPct val="100000"/>
-              </a:lnSpc>
-              <a:spcBef>
-                <a:spcPct val="0"/>
-              </a:spcBef>
-              <a:spcAft>
-                <a:spcPts val="4500"/>
-              </a:spcAft>
-              <a:buClrTx/>
-              <a:buSzTx/>
-              <a:buFontTx/>
-              <a:buNone/>
-              <a:tabLst/>
-            </a:pPr>
             <a:r>
               <a:rPr kumimoji="0" lang="en-US" altLang="en-US" sz="2200" b="1" i="0" u="none" strike="noStrike" cap="none" normalizeH="0" baseline="0" dirty="0">
                 <a:ln>
@@ -1038,161 +1180,8 @@
                 <a:effectLst/>
                 <a:latin typeface="Tw Cen MT" panose="020B0602020104020603" pitchFamily="34" charset="0"/>
               </a:rPr>
-              <a:t>Skills Learned:</a:t>
-            </a:r>
-          </a:p>
-          <a:p>
-            <a:pPr marL="0" marR="0" lvl="0" indent="0" algn="l" defTabSz="914400" rtl="0" eaLnBrk="0" fontAlgn="base" latinLnBrk="0" hangingPunct="0">
-              <a:lnSpc>
-                <a:spcPct val="100000"/>
-              </a:lnSpc>
-              <a:spcBef>
-                <a:spcPct val="0"/>
-              </a:spcBef>
-              <a:spcAft>
-                <a:spcPts val="900"/>
-              </a:spcAft>
-              <a:buClrTx/>
-              <a:buSzTx/>
-              <a:buFontTx/>
-              <a:buNone/>
-              <a:tabLst/>
-            </a:pPr>
-            <a:endParaRPr kumimoji="0" lang="en-US" altLang="en-US" sz="2200" b="1" i="0" u="none" strike="noStrike" cap="none" normalizeH="0" baseline="0" dirty="0">
-              <a:ln>
-                <a:noFill/>
-              </a:ln>
-              <a:solidFill>
-                <a:srgbClr val="000000"/>
-              </a:solidFill>
-              <a:effectLst/>
-              <a:latin typeface="Tw Cen MT" panose="020B0602020104020603" pitchFamily="34" charset="0"/>
-            </a:endParaRPr>
-          </a:p>
-          <a:p>
-            <a:pPr marL="0" marR="0" lvl="0" indent="0" algn="l" defTabSz="914400" rtl="0" eaLnBrk="0" fontAlgn="base" latinLnBrk="0" hangingPunct="0">
-              <a:lnSpc>
-                <a:spcPct val="100000"/>
-              </a:lnSpc>
-              <a:spcBef>
-                <a:spcPct val="0"/>
-              </a:spcBef>
-              <a:spcAft>
-                <a:spcPts val="900"/>
-              </a:spcAft>
-              <a:buClrTx/>
-              <a:buSzTx/>
-              <a:buFontTx/>
-              <a:buNone/>
-              <a:tabLst/>
-            </a:pPr>
-            <a:endParaRPr kumimoji="0" lang="en-US" altLang="en-US" sz="2200" b="1" i="0" u="none" strike="noStrike" cap="none" normalizeH="0" baseline="0" dirty="0">
-              <a:ln>
-                <a:noFill/>
-              </a:ln>
-              <a:solidFill>
-                <a:srgbClr val="000000"/>
-              </a:solidFill>
-              <a:effectLst/>
-              <a:latin typeface="Tw Cen MT" panose="020B0602020104020603" pitchFamily="34" charset="0"/>
-            </a:endParaRPr>
-          </a:p>
-          <a:p>
-            <a:pPr marL="0" marR="0" lvl="0" indent="0" algn="l" defTabSz="914400" rtl="0" eaLnBrk="0" fontAlgn="base" latinLnBrk="0" hangingPunct="0">
-              <a:lnSpc>
-                <a:spcPct val="100000"/>
-              </a:lnSpc>
-              <a:spcBef>
-                <a:spcPct val="0"/>
-              </a:spcBef>
-              <a:spcAft>
-                <a:spcPts val="900"/>
-              </a:spcAft>
-              <a:buClrTx/>
-              <a:buSzTx/>
-              <a:buFontTx/>
-              <a:buNone/>
-              <a:tabLst/>
-            </a:pPr>
-            <a:endParaRPr kumimoji="0" lang="en-US" altLang="en-US" sz="2200" b="1" i="0" u="none" strike="noStrike" cap="none" normalizeH="0" baseline="0" dirty="0">
-              <a:ln>
-                <a:noFill/>
-              </a:ln>
-              <a:solidFill>
-                <a:srgbClr val="000000"/>
-              </a:solidFill>
-              <a:effectLst/>
-              <a:latin typeface="Tw Cen MT" panose="020B0602020104020603" pitchFamily="34" charset="0"/>
-            </a:endParaRPr>
-          </a:p>
-          <a:p>
-            <a:pPr marL="0" marR="0" lvl="0" indent="0" algn="l" defTabSz="914400" rtl="0" eaLnBrk="0" fontAlgn="base" latinLnBrk="0" hangingPunct="0">
-              <a:lnSpc>
-                <a:spcPct val="100000"/>
-              </a:lnSpc>
-              <a:spcBef>
-                <a:spcPct val="0"/>
-              </a:spcBef>
-              <a:spcAft>
-                <a:spcPts val="900"/>
-              </a:spcAft>
-              <a:buClrTx/>
-              <a:buSzTx/>
-              <a:buFontTx/>
-              <a:buNone/>
-              <a:tabLst/>
-            </a:pPr>
-            <a:endParaRPr kumimoji="0" lang="en-US" altLang="en-US" sz="2200" b="1" i="0" u="none" strike="noStrike" cap="none" normalizeH="0" baseline="0" dirty="0">
-              <a:ln>
-                <a:noFill/>
-              </a:ln>
-              <a:solidFill>
-                <a:srgbClr val="000000"/>
-              </a:solidFill>
-              <a:effectLst/>
-              <a:latin typeface="Tw Cen MT" panose="020B0602020104020603" pitchFamily="34" charset="0"/>
-            </a:endParaRPr>
-          </a:p>
-          <a:p>
-            <a:pPr marL="0" marR="0" lvl="0" indent="0" algn="l" defTabSz="914400" rtl="0" eaLnBrk="0" fontAlgn="base" latinLnBrk="0" hangingPunct="0">
-              <a:lnSpc>
-                <a:spcPct val="100000"/>
-              </a:lnSpc>
-              <a:spcBef>
-                <a:spcPct val="0"/>
-              </a:spcBef>
-              <a:spcAft>
-                <a:spcPts val="900"/>
-              </a:spcAft>
-              <a:buClrTx/>
-              <a:buSzTx/>
-              <a:buFontTx/>
-              <a:buNone/>
-              <a:tabLst/>
-            </a:pPr>
-            <a:r>
-              <a:rPr kumimoji="0" lang="en-US" altLang="en-US" sz="2200" b="1" i="0" u="none" strike="noStrike" cap="none" normalizeH="0" baseline="0" dirty="0">
-                <a:ln>
-                  <a:noFill/>
-                </a:ln>
-                <a:solidFill>
-                  <a:srgbClr val="000000"/>
-                </a:solidFill>
-                <a:effectLst/>
-                <a:latin typeface="Tw Cen MT" panose="020B0602020104020603" pitchFamily="34" charset="0"/>
-              </a:rPr>
               <a:t>Links:</a:t>
             </a:r>
-            <a:endParaRPr kumimoji="0" lang="en-US" altLang="en-US" sz="1800" b="0" i="0" u="none" strike="noStrike" cap="none" normalizeH="0" baseline="0" dirty="0">
-              <a:ln>
-                <a:noFill/>
-              </a:ln>
-              <a:solidFill>
-                <a:schemeClr val="tx1"/>
-              </a:solidFill>
-              <a:effectLst/>
-              <a:latin typeface="Arial" panose="020B0604020202020204" pitchFamily="34" charset="0"/>
-            </a:endParaRPr>
           </a:p>
         </p:txBody>
       </p:sp>
@@ -1318,7 +1307,7 @@
           <a:p>
             <a:fld id="{A144254C-7FE5-49D4-900A-CFC9EDE1AB2E}" type="datetimeFigureOut">
               <a:rPr lang="en-US" smtClean="0"/>
-              <a:t>6/29/2026</a:t>
+              <a:t>7/19/2026</a:t>
             </a:fld>
             <a:endParaRPr lang="en-US"/>
           </a:p>
@@ -1498,7 +1487,7 @@
           <a:p>
             <a:fld id="{A144254C-7FE5-49D4-900A-CFC9EDE1AB2E}" type="datetimeFigureOut">
               <a:rPr lang="en-US" smtClean="0"/>
-              <a:t>6/29/2026</a:t>
+              <a:t>7/19/2026</a:t>
             </a:fld>
             <a:endParaRPr lang="en-US"/>
           </a:p>
@@ -1668,7 +1657,7 @@
           <a:p>
             <a:fld id="{A144254C-7FE5-49D4-900A-CFC9EDE1AB2E}" type="datetimeFigureOut">
               <a:rPr lang="en-US" smtClean="0"/>
-              <a:t>6/29/2026</a:t>
+              <a:t>7/19/2026</a:t>
             </a:fld>
             <a:endParaRPr lang="en-US"/>
           </a:p>
@@ -1912,7 +1901,7 @@
           <a:p>
             <a:fld id="{A144254C-7FE5-49D4-900A-CFC9EDE1AB2E}" type="datetimeFigureOut">
               <a:rPr lang="en-US" smtClean="0"/>
-              <a:t>6/29/2026</a:t>
+              <a:t>7/19/2026</a:t>
             </a:fld>
             <a:endParaRPr lang="en-US"/>
           </a:p>
@@ -2144,7 +2133,7 @@
           <a:p>
             <a:fld id="{A144254C-7FE5-49D4-900A-CFC9EDE1AB2E}" type="datetimeFigureOut">
               <a:rPr lang="en-US" smtClean="0"/>
-              <a:t>6/29/2026</a:t>
+              <a:t>7/19/2026</a:t>
             </a:fld>
             <a:endParaRPr lang="en-US"/>
           </a:p>
@@ -2511,7 +2500,7 @@
           <a:p>
             <a:fld id="{A144254C-7FE5-49D4-900A-CFC9EDE1AB2E}" type="datetimeFigureOut">
               <a:rPr lang="en-US" smtClean="0"/>
-              <a:t>6/29/2026</a:t>
+              <a:t>7/19/2026</a:t>
             </a:fld>
             <a:endParaRPr lang="en-US"/>
           </a:p>
@@ -2629,7 +2618,7 @@
           <a:p>
             <a:fld id="{A144254C-7FE5-49D4-900A-CFC9EDE1AB2E}" type="datetimeFigureOut">
               <a:rPr lang="en-US" smtClean="0"/>
-              <a:t>6/29/2026</a:t>
+              <a:t>7/19/2026</a:t>
             </a:fld>
             <a:endParaRPr lang="en-US"/>
           </a:p>
@@ -2724,7 +2713,7 @@
           <a:p>
             <a:fld id="{A144254C-7FE5-49D4-900A-CFC9EDE1AB2E}" type="datetimeFigureOut">
               <a:rPr lang="en-US" smtClean="0"/>
-              <a:t>6/29/2026</a:t>
+              <a:t>7/19/2026</a:t>
             </a:fld>
             <a:endParaRPr lang="en-US"/>
           </a:p>
@@ -3001,7 +2990,7 @@
           <a:p>
             <a:fld id="{A144254C-7FE5-49D4-900A-CFC9EDE1AB2E}" type="datetimeFigureOut">
               <a:rPr lang="en-US" smtClean="0"/>
-              <a:t>6/29/2026</a:t>
+              <a:t>7/19/2026</a:t>
             </a:fld>
             <a:endParaRPr lang="en-US"/>
           </a:p>
@@ -3258,7 +3247,7 @@
           <a:p>
             <a:fld id="{A144254C-7FE5-49D4-900A-CFC9EDE1AB2E}" type="datetimeFigureOut">
               <a:rPr lang="en-US" smtClean="0"/>
-              <a:t>6/29/2026</a:t>
+              <a:t>7/19/2026</a:t>
             </a:fld>
             <a:endParaRPr lang="en-US"/>
           </a:p>
@@ -3471,7 +3460,7 @@
           <a:p>
             <a:fld id="{A144254C-7FE5-49D4-900A-CFC9EDE1AB2E}" type="datetimeFigureOut">
               <a:rPr lang="en-US" smtClean="0"/>
-              <a:t>6/29/2026</a:t>
+              <a:t>7/19/2026</a:t>
             </a:fld>
             <a:endParaRPr lang="en-US"/>
           </a:p>
@@ -4221,45 +4210,12 @@
           </a:bodyPr>
           <a:lstStyle/>
           <a:p>
-            <a:pPr defTabSz="914400" eaLnBrk="0" fontAlgn="base" hangingPunct="0">
-              <a:spcBef>
-                <a:spcPct val="0"/>
-              </a:spcBef>
-              <a:spcAft>
-                <a:spcPts val="300"/>
-              </a:spcAft>
-            </a:pPr>
-            <a:r>
-              <a:rPr lang="en-US" altLang="en-US" dirty="0">
-                <a:latin typeface="Tw Cen MT"/>
+            <a:r>
+              <a:rPr lang="en-US" sz="1200" dirty="0">
+                <a:latin typeface="Tw Cen MT" panose="020B0602020104020603" pitchFamily="34" charset="0"/>
               </a:rPr>
-              <a:t>This week was all about magical characters. Our </a:t>
-            </a:r>
-            <a:r>
-              <a:rPr lang="en-US" altLang="en-US" err="1">
-                <a:latin typeface="Tw Cen MT"/>
-              </a:rPr>
-              <a:t>secon</a:t>
-            </a:r>
-            <a:r>
-              <a:rPr lang="en-US" altLang="en-US" dirty="0">
-                <a:latin typeface="Tw Cen MT"/>
-              </a:rPr>
-              <a:t>d magical character was the fairy. We listened to a story by: Alice Walsted called How to catch a garden fairy. We talked about </a:t>
-            </a:r>
-            <a:r>
-              <a:rPr lang="en-US" altLang="en-US">
-                <a:latin typeface="Tw Cen MT"/>
-              </a:rPr>
-              <a:t>some of the things </a:t>
-            </a:r>
-            <a:endParaRPr lang="en-US" altLang="en-US" sz="1800" b="0" i="0" u="none" strike="noStrike" cap="none" normalizeH="0" baseline="0" dirty="0">
-              <a:ln>
-                <a:noFill/>
-              </a:ln>
-              <a:effectLst/>
-              <a:latin typeface="Tw Cen MT"/>
-            </a:endParaRPr>
+              <a:t>Pillows are an important part of daily life because they provide comfort and support during sleep. They help keep the head, neck, and spine properly aligned, which can reduce pain and improve sleep quality. Pillows are made from various materials such as memory foam, feathers, polyester, and latex, allowing people to choose one that suits their preferences. Different sleeping positions often require different pillow types for the best support. In addition to sleeping, pillows are used for decoration, relaxation, and travel. Decorative pillows enhance the appearance of homes, while travel pillows make long journeys more comfortable. Regular cleaning and replacing old pillows helps maintain hygiene by reducing dust, allergens, and bacteria. Modern pillows also include features such as cooling fabrics and hypoallergenic materials for added comfort. Although they seem like simple household items, pillows play an important role in promoting better rest, improving overall well-being, and making everyday life more comfortable for people around the world.</a:t>
+            </a:r>
           </a:p>
         </p:txBody>
       </p:sp>
@@ -4279,7 +4235,7 @@
         </p:nvSpPr>
         <p:spPr bwMode="auto">
           <a:xfrm>
-            <a:off x="753156" y="5460256"/>
+            <a:off x="753156" y="6136630"/>
             <a:ext cx="6283325" cy="1963737"/>
           </a:xfrm>
           <a:prstGeom prst="rect">
@@ -4602,7 +4558,7 @@
         </p:nvSpPr>
         <p:spPr bwMode="auto">
           <a:xfrm>
-            <a:off x="753156" y="8148751"/>
+            <a:off x="753156" y="8500441"/>
             <a:ext cx="6194425" cy="1249362"/>
           </a:xfrm>
           <a:prstGeom prst="rect">

</xml_diff>

<commit_message>
Update activity descriptor template with full-height text boxes
The text boxes previously stopped halfway down their background cards, so
the auto-fit shrank text more than needed; full-size boxes let it stay at 12pt.

Co-Authored-By: Claude Fable 5 <noreply@anthropic.com>
Claude-Session: https://claude.ai/code/session_01XLamgTN3gmWsMSSKgWrNuv
</commit_message>
<xml_diff>
--- a/templates/activity_descriptor.pptx
+++ b/templates/activity_descriptor.pptx
@@ -4162,8 +4162,8 @@
         </p:nvSpPr>
         <p:spPr bwMode="auto">
           <a:xfrm>
-            <a:off x="753156" y="3370620"/>
-            <a:ext cx="6283325" cy="1414462"/>
+            <a:off x="753156" y="3370619"/>
+            <a:ext cx="6283325" cy="2233011"/>
           </a:xfrm>
           <a:prstGeom prst="rect">
             <a:avLst/>
@@ -4212,7 +4212,8 @@
           <a:p>
             <a:r>
               <a:rPr lang="en-US" sz="1200" dirty="0">
-                <a:latin typeface="Tw Cen MT" panose="020B0602020104020603" pitchFamily="34" charset="0"/>
+                <a:latin typeface="Times New Roman" panose="02020603050405020304" pitchFamily="18" charset="0"/>
+                <a:cs typeface="Times New Roman" panose="02020603050405020304" pitchFamily="18" charset="0"/>
               </a:rPr>
               <a:t>Pillows are an important part of daily life because they provide comfort and support during sleep. They help keep the head, neck, and spine properly aligned, which can reduce pain and improve sleep quality. Pillows are made from various materials such as memory foam, feathers, polyester, and latex, allowing people to choose one that suits their preferences. Different sleeping positions often require different pillow types for the best support. In addition to sleeping, pillows are used for decoration, relaxation, and travel. Decorative pillows enhance the appearance of homes, while travel pillows make long journeys more comfortable. Regular cleaning and replacing old pillows helps maintain hygiene by reducing dust, allergens, and bacteria. Modern pillows also include features such as cooling fabrics and hypoallergenic materials for added comfort. Although they seem like simple household items, pillows play an important role in promoting better rest, improving overall well-being, and making everyday life more comfortable for people around the world.</a:t>
             </a:r>
@@ -4308,7 +4309,8 @@
                   <a:srgbClr val="000000"/>
                 </a:solidFill>
                 <a:effectLst/>
-                <a:latin typeface="Tw Cen MT" panose="020B0602020104020603" pitchFamily="34" charset="0"/>
+                <a:latin typeface="Times New Roman" panose="02020603050405020304" pitchFamily="18" charset="0"/>
+                <a:cs typeface="Times New Roman" panose="02020603050405020304" pitchFamily="18" charset="0"/>
               </a:rPr>
               <a:t>Associates meaning to familiar words</a:t>
             </a:r>
@@ -4339,7 +4341,8 @@
                   <a:srgbClr val="000000"/>
                 </a:solidFill>
                 <a:effectLst/>
-                <a:latin typeface="Tw Cen MT" panose="020B0602020104020603" pitchFamily="34" charset="0"/>
+                <a:latin typeface="Times New Roman" panose="02020603050405020304" pitchFamily="18" charset="0"/>
+                <a:cs typeface="Times New Roman" panose="02020603050405020304" pitchFamily="18" charset="0"/>
               </a:rPr>
               <a:t>Attends to baby sign language</a:t>
             </a:r>
@@ -4370,7 +4373,8 @@
                   <a:srgbClr val="000000"/>
                 </a:solidFill>
                 <a:effectLst/>
-                <a:latin typeface="Tw Cen MT" panose="020B0602020104020603" pitchFamily="34" charset="0"/>
+                <a:latin typeface="Times New Roman" panose="02020603050405020304" pitchFamily="18" charset="0"/>
+                <a:cs typeface="Times New Roman" panose="02020603050405020304" pitchFamily="18" charset="0"/>
               </a:rPr>
               <a:t>Reaches for toys</a:t>
             </a:r>
@@ -4401,7 +4405,8 @@
                   <a:srgbClr val="000000"/>
                 </a:solidFill>
                 <a:effectLst/>
-                <a:latin typeface="Tw Cen MT" panose="020B0602020104020603" pitchFamily="34" charset="0"/>
+                <a:latin typeface="Times New Roman" panose="02020603050405020304" pitchFamily="18" charset="0"/>
+                <a:cs typeface="Times New Roman" panose="02020603050405020304" pitchFamily="18" charset="0"/>
               </a:rPr>
               <a:t>Grasps toys</a:t>
             </a:r>
@@ -4432,7 +4437,8 @@
                   <a:srgbClr val="000000"/>
                 </a:solidFill>
                 <a:effectLst/>
-                <a:latin typeface="Tw Cen MT" panose="020B0602020104020603" pitchFamily="34" charset="0"/>
+                <a:latin typeface="Times New Roman" panose="02020603050405020304" pitchFamily="18" charset="0"/>
+                <a:cs typeface="Times New Roman" panose="02020603050405020304" pitchFamily="18" charset="0"/>
               </a:rPr>
               <a:t>Uses fingers and palms to hold objects</a:t>
             </a:r>
@@ -4463,7 +4469,8 @@
                   <a:srgbClr val="000000"/>
                 </a:solidFill>
                 <a:effectLst/>
-                <a:latin typeface="Tw Cen MT" panose="020B0602020104020603" pitchFamily="34" charset="0"/>
+                <a:latin typeface="Times New Roman" panose="02020603050405020304" pitchFamily="18" charset="0"/>
+                <a:cs typeface="Times New Roman" panose="02020603050405020304" pitchFamily="18" charset="0"/>
               </a:rPr>
               <a:t>Explores texture and sensation</a:t>
             </a:r>
@@ -4494,7 +4501,8 @@
                   <a:srgbClr val="000000"/>
                 </a:solidFill>
                 <a:effectLst/>
-                <a:latin typeface="Tw Cen MT" panose="020B0602020104020603" pitchFamily="34" charset="0"/>
+                <a:latin typeface="Times New Roman" panose="02020603050405020304" pitchFamily="18" charset="0"/>
+                <a:cs typeface="Times New Roman" panose="02020603050405020304" pitchFamily="18" charset="0"/>
               </a:rPr>
               <a:t>Explores multi-sensory activities</a:t>
             </a:r>
@@ -4525,7 +4533,8 @@
                   <a:srgbClr val="000000"/>
                 </a:solidFill>
                 <a:effectLst/>
-                <a:latin typeface="Tw Cen MT" panose="020B0602020104020603" pitchFamily="34" charset="0"/>
+                <a:latin typeface="Times New Roman" panose="02020603050405020304" pitchFamily="18" charset="0"/>
+                <a:cs typeface="Times New Roman" panose="02020603050405020304" pitchFamily="18" charset="0"/>
               </a:rPr>
               <a:t>Shows some understanding of cause and effect</a:t>
             </a:r>
@@ -4537,7 +4546,8 @@
                 <a:schemeClr val="tx1"/>
               </a:solidFill>
               <a:effectLst/>
-              <a:latin typeface="Arial" panose="020B0604020202020204" pitchFamily="34" charset="0"/>
+              <a:latin typeface="Times New Roman" panose="02020603050405020304" pitchFamily="18" charset="0"/>
+              <a:cs typeface="Times New Roman" panose="02020603050405020304" pitchFamily="18" charset="0"/>
             </a:endParaRPr>
           </a:p>
         </p:txBody>
@@ -4559,7 +4569,7 @@
         <p:spPr bwMode="auto">
           <a:xfrm>
             <a:off x="753156" y="8500441"/>
-            <a:ext cx="6194425" cy="1249362"/>
+            <a:ext cx="6194425" cy="1171097"/>
           </a:xfrm>
           <a:prstGeom prst="rect">
             <a:avLst/>
@@ -4631,7 +4641,8 @@
                   <a:srgbClr val="000000"/>
                 </a:solidFill>
                 <a:effectLst/>
-                <a:latin typeface="Tw Cen MT" panose="020B0602020104020603" pitchFamily="34" charset="0"/>
+                <a:latin typeface="Times New Roman" panose="02020603050405020304" pitchFamily="18" charset="0"/>
+                <a:cs typeface="Times New Roman" panose="02020603050405020304" pitchFamily="18" charset="0"/>
               </a:rPr>
               <a:t>Language and Literacy</a:t>
             </a:r>
@@ -4662,7 +4673,8 @@
                   <a:srgbClr val="000000"/>
                 </a:solidFill>
                 <a:effectLst/>
-                <a:latin typeface="Tw Cen MT" panose="020B0602020104020603" pitchFamily="34" charset="0"/>
+                <a:latin typeface="Times New Roman" panose="02020603050405020304" pitchFamily="18" charset="0"/>
+                <a:cs typeface="Times New Roman" panose="02020603050405020304" pitchFamily="18" charset="0"/>
               </a:rPr>
               <a:t>Wellness</a:t>
             </a:r>
@@ -4693,7 +4705,8 @@
                   <a:srgbClr val="000000"/>
                 </a:solidFill>
                 <a:effectLst/>
-                <a:latin typeface="Tw Cen MT" panose="020B0602020104020603" pitchFamily="34" charset="0"/>
+                <a:latin typeface="Times New Roman" panose="02020603050405020304" pitchFamily="18" charset="0"/>
+                <a:cs typeface="Times New Roman" panose="02020603050405020304" pitchFamily="18" charset="0"/>
               </a:rPr>
               <a:t>Creative Expression</a:t>
             </a:r>
@@ -4724,7 +4737,8 @@
                   <a:srgbClr val="000000"/>
                 </a:solidFill>
                 <a:effectLst/>
-                <a:latin typeface="Tw Cen MT" panose="020B0602020104020603" pitchFamily="34" charset="0"/>
+                <a:latin typeface="Times New Roman" panose="02020603050405020304" pitchFamily="18" charset="0"/>
+                <a:cs typeface="Times New Roman" panose="02020603050405020304" pitchFamily="18" charset="0"/>
               </a:rPr>
               <a:t>Mathematics</a:t>
             </a:r>
@@ -4755,7 +4769,8 @@
                   <a:srgbClr val="000000"/>
                 </a:solidFill>
                 <a:effectLst/>
-                <a:latin typeface="Tw Cen MT" panose="020B0602020104020603" pitchFamily="34" charset="0"/>
+                <a:latin typeface="Times New Roman" panose="02020603050405020304" pitchFamily="18" charset="0"/>
+                <a:cs typeface="Times New Roman" panose="02020603050405020304" pitchFamily="18" charset="0"/>
               </a:rPr>
               <a:t>Social Emotional</a:t>
             </a:r>
@@ -4767,7 +4782,8 @@
                 <a:schemeClr val="tx1"/>
               </a:solidFill>
               <a:effectLst/>
-              <a:latin typeface="Arial" panose="020B0604020202020204" pitchFamily="34" charset="0"/>
+              <a:latin typeface="Times New Roman" panose="02020603050405020304" pitchFamily="18" charset="0"/>
+              <a:cs typeface="Times New Roman" panose="02020603050405020304" pitchFamily="18" charset="0"/>
             </a:endParaRPr>
           </a:p>
         </p:txBody>
@@ -5275,32 +5291,6 @@
 </file>
 
 <file path=customXml/item2.xml><?xml version="1.0" encoding="utf-8"?>
-<p:properties xmlns:p="http://schemas.microsoft.com/office/2006/metadata/properties" xmlns:xsi="http://www.w3.org/2001/XMLSchema-instance" xmlns:pc="http://schemas.microsoft.com/office/infopath/2007/PartnerControls">
-  <documentManagement>
-    <_dlc_DocId xmlns="46c134e8-bef0-482e-9f1c-a7294db10c31">RZXFP22AZQT3-1443949671-2</_dlc_DocId>
-    <_dlc_DocIdUrl xmlns="46c134e8-bef0-482e-9f1c-a7294db10c31">
-      <Url>https://nlcinccom.sharepoint.com/ed/_layouts/15/DocIdRedir.aspx?ID=RZXFP22AZQT3-1443949671-2</Url>
-      <Description>RZXFP22AZQT3-1443949671-2</Description>
-    </_dlc_DocIdUrl>
-    <lcf76f155ced4ddcb4097134ff3c332f xmlns="1d23d722-efd0-4caf-8689-3c9efa67bc8c">
-      <Terms xmlns="http://schemas.microsoft.com/office/infopath/2007/PartnerControls"/>
-    </lcf76f155ced4ddcb4097134ff3c332f>
-    <TaxCatchAll xmlns="46c134e8-bef0-482e-9f1c-a7294db10c31" xsi:nil="true"/>
-    <Description xmlns="1d23d722-efd0-4caf-8689-3c9efa67bc8c" xsi:nil="true"/>
-  </documentManagement>
-</p:properties>
-</file>
-
-<file path=customXml/item3.xml><?xml version="1.0" encoding="utf-8"?>
-<?mso-contentType ?>
-<FormTemplates xmlns="http://schemas.microsoft.com/sharepoint/v3/contenttype/forms">
-  <Display>DocumentLibraryForm</Display>
-  <Edit>DocumentLibraryForm</Edit>
-  <New>DocumentLibraryForm</New>
-</FormTemplates>
-</file>
-
-<file path=customXml/item4.xml><?xml version="1.0" encoding="utf-8"?>
 <?mso-contentType ?>
 <spe:Receivers xmlns:spe="http://schemas.microsoft.com/sharepoint/events">
   <Receiver>
@@ -5350,6 +5340,32 @@
 </spe:Receivers>
 </file>
 
+<file path=customXml/item3.xml><?xml version="1.0" encoding="utf-8"?>
+<?mso-contentType ?>
+<FormTemplates xmlns="http://schemas.microsoft.com/sharepoint/v3/contenttype/forms">
+  <Display>DocumentLibraryForm</Display>
+  <Edit>DocumentLibraryForm</Edit>
+  <New>DocumentLibraryForm</New>
+</FormTemplates>
+</file>
+
+<file path=customXml/item4.xml><?xml version="1.0" encoding="utf-8"?>
+<p:properties xmlns:p="http://schemas.microsoft.com/office/2006/metadata/properties" xmlns:xsi="http://www.w3.org/2001/XMLSchema-instance" xmlns:pc="http://schemas.microsoft.com/office/infopath/2007/PartnerControls">
+  <documentManagement>
+    <_dlc_DocId xmlns="46c134e8-bef0-482e-9f1c-a7294db10c31">RZXFP22AZQT3-1443949671-2</_dlc_DocId>
+    <_dlc_DocIdUrl xmlns="46c134e8-bef0-482e-9f1c-a7294db10c31">
+      <Url>https://nlcinccom.sharepoint.com/ed/_layouts/15/DocIdRedir.aspx?ID=RZXFP22AZQT3-1443949671-2</Url>
+      <Description>RZXFP22AZQT3-1443949671-2</Description>
+    </_dlc_DocIdUrl>
+    <lcf76f155ced4ddcb4097134ff3c332f xmlns="1d23d722-efd0-4caf-8689-3c9efa67bc8c">
+      <Terms xmlns="http://schemas.microsoft.com/office/infopath/2007/PartnerControls"/>
+    </lcf76f155ced4ddcb4097134ff3c332f>
+    <TaxCatchAll xmlns="46c134e8-bef0-482e-9f1c-a7294db10c31" xsi:nil="true"/>
+    <Description xmlns="1d23d722-efd0-4caf-8689-3c9efa67bc8c" xsi:nil="true"/>
+  </documentManagement>
+</p:properties>
+</file>
+
 <file path=customXml/itemProps1.xml><?xml version="1.0" encoding="utf-8"?>
 <ds:datastoreItem xmlns:ds="http://schemas.openxmlformats.org/officeDocument/2006/customXml" ds:itemID="{D32A58ED-0C81-4BE2-A97E-1C90CB8E0AAE}">
   <ds:schemaRefs>
@@ -5370,6 +5386,22 @@
 </file>
 
 <file path=customXml/itemProps2.xml><?xml version="1.0" encoding="utf-8"?>
+<ds:datastoreItem xmlns:ds="http://schemas.openxmlformats.org/officeDocument/2006/customXml" ds:itemID="{EB40C345-5DED-434E-935D-D46D1B16FFBC}">
+  <ds:schemaRefs>
+    <ds:schemaRef ds:uri="http://schemas.microsoft.com/sharepoint/events"/>
+  </ds:schemaRefs>
+</ds:datastoreItem>
+</file>
+
+<file path=customXml/itemProps3.xml><?xml version="1.0" encoding="utf-8"?>
+<ds:datastoreItem xmlns:ds="http://schemas.openxmlformats.org/officeDocument/2006/customXml" ds:itemID="{E579EB95-1973-4674-B241-1BCE1991650D}">
+  <ds:schemaRefs>
+    <ds:schemaRef ds:uri="http://schemas.microsoft.com/sharepoint/v3/contenttype/forms"/>
+  </ds:schemaRefs>
+</ds:datastoreItem>
+</file>
+
+<file path=customXml/itemProps4.xml><?xml version="1.0" encoding="utf-8"?>
 <ds:datastoreItem xmlns:ds="http://schemas.openxmlformats.org/officeDocument/2006/customXml" ds:itemID="{6E592711-B571-4DAB-A88F-D321DDCDD15C}">
   <ds:schemaRefs>
     <ds:schemaRef ds:uri="http://purl.org/dc/terms/"/>
@@ -5384,20 +5416,4 @@
     <ds:schemaRef ds:uri="46c134e8-bef0-482e-9f1c-a7294db10c31"/>
   </ds:schemaRefs>
 </ds:datastoreItem>
-</file>
-
-<file path=customXml/itemProps3.xml><?xml version="1.0" encoding="utf-8"?>
-<ds:datastoreItem xmlns:ds="http://schemas.openxmlformats.org/officeDocument/2006/customXml" ds:itemID="{E579EB95-1973-4674-B241-1BCE1991650D}">
-  <ds:schemaRefs>
-    <ds:schemaRef ds:uri="http://schemas.microsoft.com/sharepoint/v3/contenttype/forms"/>
-  </ds:schemaRefs>
-</ds:datastoreItem>
-</file>
-
-<file path=customXml/itemProps4.xml><?xml version="1.0" encoding="utf-8"?>
-<ds:datastoreItem xmlns:ds="http://schemas.openxmlformats.org/officeDocument/2006/customXml" ds:itemID="{EB40C345-5DED-434E-935D-D46D1B16FFBC}">
-  <ds:schemaRefs>
-    <ds:schemaRef ds:uri="http://schemas.microsoft.com/sharepoint/events"/>
-  </ds:schemaRefs>
-</ds:datastoreItem>
 </file>
</xml_diff>